<commit_message>
tools: actualizar PPT con capturas de codigo + script de arreglo del docx
- PPT regenerado desde cero con 6 slides limpias (sin XML duplicado)
- Slide nueva: capturas con syntax highlighting del codigo
- Slide simplificada: como mide la fisica (con analogias)
- Slide nueva: con que esta hecho (Python, OpenCV, NumPy, GitHub Pages)
- Script auxiliar: arreglar_documento.py (renumera secciones del Word)
- Script auxiliar: actualizar_ppt.py (regenera PPT con capturas)

Co-Authored-By: Claude Sonnet 4.6 <noreply@anthropic.com>
</commit_message>
<xml_diff>
--- a/informe/Exposicion_PhysicsMotionAnalyzer.pptx
+++ b/informe/Exposicion_PhysicsMotionAnalyzer.pptx
@@ -9,6 +9,8 @@
     <p:sldId id="257" r:id="rId8"/>
     <p:sldId id="258" r:id="rId9"/>
     <p:sldId id="259" r:id="rId10"/>
+    <p:sldId id="260" r:id="rId11"/>
+    <p:sldId id="261" r:id="rId12"/>
   </p:sldIdLst>
   <p:sldSz cx="12188952" cy="6858000" type="screen4x3"/>
   <p:notesSz cx="6858000" cy="9144000"/>
@@ -5509,6 +5511,1978 @@
 </file>
 
 <file path=ppt/slides/slide4.xml><?xml version="1.0" encoding="utf-8"?>
+<p:sld xmlns:a="http://schemas.openxmlformats.org/drawingml/2006/main" xmlns:p="http://schemas.openxmlformats.org/presentationml/2006/main" xmlns:r="http://schemas.openxmlformats.org/officeDocument/2006/relationships">
+  <p:cSld>
+    <p:spTree>
+      <p:nvGrpSpPr>
+        <p:cNvPr id="1" name=""/>
+        <p:cNvGrpSpPr/>
+        <p:nvPr/>
+      </p:nvGrpSpPr>
+      <p:grpSpPr/>
+      <p:sp>
+        <p:nvSpPr>
+          <p:cNvPr id="2" name="Rectangle 1"/>
+          <p:cNvSpPr/>
+          <p:nvPr/>
+        </p:nvSpPr>
+        <p:spPr>
+          <a:xfrm>
+            <a:off x="0" y="0"/>
+            <a:ext cx="12188952" cy="6858000"/>
+          </a:xfrm>
+          <a:prstGeom prst="rect">
+            <a:avLst/>
+          </a:prstGeom>
+          <a:solidFill>
+            <a:srgbClr val="FFFFFF"/>
+          </a:solidFill>
+          <a:ln>
+            <a:noFill/>
+          </a:ln>
+          <a:effectLst/>
+        </p:spPr>
+        <p:style>
+          <a:lnRef idx="1">
+            <a:schemeClr val="accent1"/>
+          </a:lnRef>
+          <a:fillRef idx="3">
+            <a:schemeClr val="accent1"/>
+          </a:fillRef>
+          <a:effectRef idx="2">
+            <a:schemeClr val="accent1"/>
+          </a:effectRef>
+          <a:fontRef idx="minor">
+            <a:schemeClr val="lt1"/>
+          </a:fontRef>
+        </p:style>
+        <p:txBody>
+          <a:bodyPr rtlCol="0" anchor="ctr"/>
+          <a:lstStyle/>
+          <a:p>
+            <a:pPr algn="ctr"/>
+          </a:p>
+        </p:txBody>
+      </p:sp>
+      <p:sp>
+        <p:nvSpPr>
+          <p:cNvPr id="3" name="Rectangle 2"/>
+          <p:cNvSpPr/>
+          <p:nvPr/>
+        </p:nvSpPr>
+        <p:spPr>
+          <a:xfrm>
+            <a:off x="0" y="0"/>
+            <a:ext cx="12188952" cy="640080"/>
+          </a:xfrm>
+          <a:prstGeom prst="rect">
+            <a:avLst/>
+          </a:prstGeom>
+          <a:solidFill>
+            <a:srgbClr val="0F172A"/>
+          </a:solidFill>
+          <a:ln>
+            <a:noFill/>
+          </a:ln>
+          <a:effectLst/>
+        </p:spPr>
+        <p:style>
+          <a:lnRef idx="1">
+            <a:schemeClr val="accent1"/>
+          </a:lnRef>
+          <a:fillRef idx="3">
+            <a:schemeClr val="accent1"/>
+          </a:fillRef>
+          <a:effectRef idx="2">
+            <a:schemeClr val="accent1"/>
+          </a:effectRef>
+          <a:fontRef idx="minor">
+            <a:schemeClr val="lt1"/>
+          </a:fontRef>
+        </p:style>
+        <p:txBody>
+          <a:bodyPr rtlCol="0" anchor="ctr"/>
+          <a:lstStyle/>
+          <a:p>
+            <a:pPr algn="ctr"/>
+          </a:p>
+        </p:txBody>
+      </p:sp>
+      <p:sp>
+        <p:nvSpPr>
+          <p:cNvPr id="4" name="TextBox 3"/>
+          <p:cNvSpPr txBox="1"/>
+          <p:nvPr/>
+        </p:nvSpPr>
+        <p:spPr>
+          <a:xfrm>
+            <a:off x="457200" y="137160"/>
+            <a:ext cx="10972800" cy="411480"/>
+          </a:xfrm>
+          <a:prstGeom prst="rect">
+            <a:avLst/>
+          </a:prstGeom>
+          <a:noFill/>
+        </p:spPr>
+        <p:txBody>
+          <a:bodyPr wrap="square" lIns="45720" rIns="45720">
+            <a:spAutoFit/>
+          </a:bodyPr>
+          <a:lstStyle/>
+          <a:p>
+            <a:pPr algn="l"/>
+            <a:r>
+              <a:rPr sz="1800" b="1">
+                <a:solidFill>
+                  <a:srgbClr val="FFFFFF"/>
+                </a:solidFill>
+                <a:latin typeface="Segoe UI"/>
+              </a:rPr>
+              <a:t>TECNOLOGÍA Y VALOR AGREGADO</a:t>
+            </a:r>
+          </a:p>
+        </p:txBody>
+      </p:sp>
+      <p:sp>
+        <p:nvSpPr>
+          <p:cNvPr id="5" name="TextBox 4"/>
+          <p:cNvSpPr txBox="1"/>
+          <p:nvPr/>
+        </p:nvSpPr>
+        <p:spPr>
+          <a:xfrm>
+            <a:off x="548640" y="914400"/>
+            <a:ext cx="10972800" cy="548640"/>
+          </a:xfrm>
+          <a:prstGeom prst="rect">
+            <a:avLst/>
+          </a:prstGeom>
+          <a:noFill/>
+        </p:spPr>
+        <p:txBody>
+          <a:bodyPr wrap="square" lIns="45720" rIns="45720">
+            <a:spAutoFit/>
+          </a:bodyPr>
+          <a:lstStyle/>
+          <a:p>
+            <a:pPr algn="l"/>
+            <a:r>
+              <a:rPr sz="2000" b="1">
+                <a:solidFill>
+                  <a:srgbClr val="0F172A"/>
+                </a:solidFill>
+                <a:latin typeface="Segoe UI"/>
+              </a:rPr>
+              <a:t>Cómo está construido el sistema</a:t>
+            </a:r>
+          </a:p>
+        </p:txBody>
+      </p:sp>
+      <p:sp>
+        <p:nvSpPr>
+          <p:cNvPr id="6" name="TextBox 5"/>
+          <p:cNvSpPr txBox="1"/>
+          <p:nvPr/>
+        </p:nvSpPr>
+        <p:spPr>
+          <a:xfrm>
+            <a:off x="640080" y="1737360"/>
+            <a:ext cx="5486400" cy="365760"/>
+          </a:xfrm>
+          <a:prstGeom prst="rect">
+            <a:avLst/>
+          </a:prstGeom>
+          <a:noFill/>
+        </p:spPr>
+        <p:txBody>
+          <a:bodyPr wrap="square" lIns="45720" rIns="45720">
+            <a:spAutoFit/>
+          </a:bodyPr>
+          <a:lstStyle/>
+          <a:p>
+            <a:pPr algn="l"/>
+            <a:r>
+              <a:rPr sz="1400" b="1">
+                <a:solidFill>
+                  <a:srgbClr val="2563EB"/>
+                </a:solidFill>
+                <a:latin typeface="Segoe UI"/>
+              </a:rPr>
+              <a:t>🛠 Stack tecnológico</a:t>
+            </a:r>
+          </a:p>
+        </p:txBody>
+      </p:sp>
+      <p:sp>
+        <p:nvSpPr>
+          <p:cNvPr id="7" name="TextBox 6"/>
+          <p:cNvSpPr txBox="1"/>
+          <p:nvPr/>
+        </p:nvSpPr>
+        <p:spPr>
+          <a:xfrm>
+            <a:off x="822960" y="2194560"/>
+            <a:ext cx="1554480" cy="365760"/>
+          </a:xfrm>
+          <a:prstGeom prst="rect">
+            <a:avLst/>
+          </a:prstGeom>
+          <a:noFill/>
+        </p:spPr>
+        <p:txBody>
+          <a:bodyPr wrap="square" lIns="45720" rIns="45720">
+            <a:spAutoFit/>
+          </a:bodyPr>
+          <a:lstStyle/>
+          <a:p>
+            <a:pPr algn="l"/>
+            <a:r>
+              <a:rPr sz="1000" b="1">
+                <a:solidFill>
+                  <a:srgbClr val="0F172A"/>
+                </a:solidFill>
+                <a:latin typeface="Segoe UI"/>
+              </a:rPr>
+              <a:t>● Python 3.14</a:t>
+            </a:r>
+          </a:p>
+        </p:txBody>
+      </p:sp>
+      <p:sp>
+        <p:nvSpPr>
+          <p:cNvPr id="8" name="TextBox 7"/>
+          <p:cNvSpPr txBox="1"/>
+          <p:nvPr/>
+        </p:nvSpPr>
+        <p:spPr>
+          <a:xfrm>
+            <a:off x="2377440" y="2194560"/>
+            <a:ext cx="3840480" cy="365760"/>
+          </a:xfrm>
+          <a:prstGeom prst="rect">
+            <a:avLst/>
+          </a:prstGeom>
+          <a:noFill/>
+        </p:spPr>
+        <p:txBody>
+          <a:bodyPr wrap="square" lIns="45720" rIns="45720">
+            <a:spAutoFit/>
+          </a:bodyPr>
+          <a:lstStyle/>
+          <a:p>
+            <a:pPr algn="l"/>
+            <a:r>
+              <a:rPr sz="900" b="0">
+                <a:solidFill>
+                  <a:srgbClr val="64748B"/>
+                </a:solidFill>
+                <a:latin typeface="Segoe UI"/>
+              </a:rPr>
+              <a:t>Lenguaje principal, ideal para IA y visión por computadora</a:t>
+            </a:r>
+          </a:p>
+        </p:txBody>
+      </p:sp>
+      <p:sp>
+        <p:nvSpPr>
+          <p:cNvPr id="9" name="TextBox 8"/>
+          <p:cNvSpPr txBox="1"/>
+          <p:nvPr/>
+        </p:nvSpPr>
+        <p:spPr>
+          <a:xfrm>
+            <a:off x="822960" y="2651760"/>
+            <a:ext cx="1554480" cy="365760"/>
+          </a:xfrm>
+          <a:prstGeom prst="rect">
+            <a:avLst/>
+          </a:prstGeom>
+          <a:noFill/>
+        </p:spPr>
+        <p:txBody>
+          <a:bodyPr wrap="square" lIns="45720" rIns="45720">
+            <a:spAutoFit/>
+          </a:bodyPr>
+          <a:lstStyle/>
+          <a:p>
+            <a:pPr algn="l"/>
+            <a:r>
+              <a:rPr sz="1000" b="1">
+                <a:solidFill>
+                  <a:srgbClr val="0F172A"/>
+                </a:solidFill>
+                <a:latin typeface="Segoe UI"/>
+              </a:rPr>
+              <a:t>● OpenCV 4.13</a:t>
+            </a:r>
+          </a:p>
+        </p:txBody>
+      </p:sp>
+      <p:sp>
+        <p:nvSpPr>
+          <p:cNvPr id="10" name="TextBox 9"/>
+          <p:cNvSpPr txBox="1"/>
+          <p:nvPr/>
+        </p:nvSpPr>
+        <p:spPr>
+          <a:xfrm>
+            <a:off x="2377440" y="2651760"/>
+            <a:ext cx="3840480" cy="365760"/>
+          </a:xfrm>
+          <a:prstGeom prst="rect">
+            <a:avLst/>
+          </a:prstGeom>
+          <a:noFill/>
+        </p:spPr>
+        <p:txBody>
+          <a:bodyPr wrap="square" lIns="45720" rIns="45720">
+            <a:spAutoFit/>
+          </a:bodyPr>
+          <a:lstStyle/>
+          <a:p>
+            <a:pPr algn="l"/>
+            <a:r>
+              <a:rPr sz="900" b="0">
+                <a:solidFill>
+                  <a:srgbClr val="64748B"/>
+                </a:solidFill>
+                <a:latin typeface="Segoe UI"/>
+              </a:rPr>
+              <a:t>Procesamiento de video, detección por color HSV, contornos</a:t>
+            </a:r>
+          </a:p>
+        </p:txBody>
+      </p:sp>
+      <p:sp>
+        <p:nvSpPr>
+          <p:cNvPr id="11" name="TextBox 10"/>
+          <p:cNvSpPr txBox="1"/>
+          <p:nvPr/>
+        </p:nvSpPr>
+        <p:spPr>
+          <a:xfrm>
+            <a:off x="822960" y="3108960"/>
+            <a:ext cx="1554480" cy="365760"/>
+          </a:xfrm>
+          <a:prstGeom prst="rect">
+            <a:avLst/>
+          </a:prstGeom>
+          <a:noFill/>
+        </p:spPr>
+        <p:txBody>
+          <a:bodyPr wrap="square" lIns="45720" rIns="45720">
+            <a:spAutoFit/>
+          </a:bodyPr>
+          <a:lstStyle/>
+          <a:p>
+            <a:pPr algn="l"/>
+            <a:r>
+              <a:rPr sz="1000" b="1">
+                <a:solidFill>
+                  <a:srgbClr val="0F172A"/>
+                </a:solidFill>
+                <a:latin typeface="Segoe UI"/>
+              </a:rPr>
+              <a:t>● NumPy + SciPy</a:t>
+            </a:r>
+          </a:p>
+        </p:txBody>
+      </p:sp>
+      <p:sp>
+        <p:nvSpPr>
+          <p:cNvPr id="12" name="TextBox 11"/>
+          <p:cNvSpPr txBox="1"/>
+          <p:nvPr/>
+        </p:nvSpPr>
+        <p:spPr>
+          <a:xfrm>
+            <a:off x="2377440" y="3108960"/>
+            <a:ext cx="3840480" cy="365760"/>
+          </a:xfrm>
+          <a:prstGeom prst="rect">
+            <a:avLst/>
+          </a:prstGeom>
+          <a:noFill/>
+        </p:spPr>
+        <p:txBody>
+          <a:bodyPr wrap="square" lIns="45720" rIns="45720">
+            <a:spAutoFit/>
+          </a:bodyPr>
+          <a:lstStyle/>
+          <a:p>
+            <a:pPr algn="l"/>
+            <a:r>
+              <a:rPr sz="900" b="0">
+                <a:solidFill>
+                  <a:srgbClr val="64748B"/>
+                </a:solidFill>
+                <a:latin typeface="Segoe UI"/>
+              </a:rPr>
+              <a:t>Cálculos numéricos: derivadas, filtro Savitzky-Golay</a:t>
+            </a:r>
+          </a:p>
+        </p:txBody>
+      </p:sp>
+      <p:sp>
+        <p:nvSpPr>
+          <p:cNvPr id="13" name="TextBox 12"/>
+          <p:cNvSpPr txBox="1"/>
+          <p:nvPr/>
+        </p:nvSpPr>
+        <p:spPr>
+          <a:xfrm>
+            <a:off x="822960" y="3566160"/>
+            <a:ext cx="1554480" cy="365760"/>
+          </a:xfrm>
+          <a:prstGeom prst="rect">
+            <a:avLst/>
+          </a:prstGeom>
+          <a:noFill/>
+        </p:spPr>
+        <p:txBody>
+          <a:bodyPr wrap="square" lIns="45720" rIns="45720">
+            <a:spAutoFit/>
+          </a:bodyPr>
+          <a:lstStyle/>
+          <a:p>
+            <a:pPr algn="l"/>
+            <a:r>
+              <a:rPr sz="1000" b="1">
+                <a:solidFill>
+                  <a:srgbClr val="0F172A"/>
+                </a:solidFill>
+                <a:latin typeface="Segoe UI"/>
+              </a:rPr>
+              <a:t>● Matplotlib</a:t>
+            </a:r>
+          </a:p>
+        </p:txBody>
+      </p:sp>
+      <p:sp>
+        <p:nvSpPr>
+          <p:cNvPr id="14" name="TextBox 13"/>
+          <p:cNvSpPr txBox="1"/>
+          <p:nvPr/>
+        </p:nvSpPr>
+        <p:spPr>
+          <a:xfrm>
+            <a:off x="2377440" y="3566160"/>
+            <a:ext cx="3840480" cy="365760"/>
+          </a:xfrm>
+          <a:prstGeom prst="rect">
+            <a:avLst/>
+          </a:prstGeom>
+          <a:noFill/>
+        </p:spPr>
+        <p:txBody>
+          <a:bodyPr wrap="square" lIns="45720" rIns="45720">
+            <a:spAutoFit/>
+          </a:bodyPr>
+          <a:lstStyle/>
+          <a:p>
+            <a:pPr algn="l"/>
+            <a:r>
+              <a:rPr sz="900" b="0">
+                <a:solidFill>
+                  <a:srgbClr val="64748B"/>
+                </a:solidFill>
+                <a:latin typeface="Segoe UI"/>
+              </a:rPr>
+              <a:t>Gráficas de posición, velocidad y aceleración</a:t>
+            </a:r>
+          </a:p>
+        </p:txBody>
+      </p:sp>
+      <p:sp>
+        <p:nvSpPr>
+          <p:cNvPr id="15" name="TextBox 14"/>
+          <p:cNvSpPr txBox="1"/>
+          <p:nvPr/>
+        </p:nvSpPr>
+        <p:spPr>
+          <a:xfrm>
+            <a:off x="822960" y="4023360"/>
+            <a:ext cx="1554480" cy="365760"/>
+          </a:xfrm>
+          <a:prstGeom prst="rect">
+            <a:avLst/>
+          </a:prstGeom>
+          <a:noFill/>
+        </p:spPr>
+        <p:txBody>
+          <a:bodyPr wrap="square" lIns="45720" rIns="45720">
+            <a:spAutoFit/>
+          </a:bodyPr>
+          <a:lstStyle/>
+          <a:p>
+            <a:pPr algn="l"/>
+            <a:r>
+              <a:rPr sz="1000" b="1">
+                <a:solidFill>
+                  <a:srgbClr val="0F172A"/>
+                </a:solidFill>
+                <a:latin typeface="Segoe UI"/>
+              </a:rPr>
+              <a:t>● Tkinter</a:t>
+            </a:r>
+          </a:p>
+        </p:txBody>
+      </p:sp>
+      <p:sp>
+        <p:nvSpPr>
+          <p:cNvPr id="16" name="TextBox 15"/>
+          <p:cNvSpPr txBox="1"/>
+          <p:nvPr/>
+        </p:nvSpPr>
+        <p:spPr>
+          <a:xfrm>
+            <a:off x="2377440" y="4023360"/>
+            <a:ext cx="3840480" cy="365760"/>
+          </a:xfrm>
+          <a:prstGeom prst="rect">
+            <a:avLst/>
+          </a:prstGeom>
+          <a:noFill/>
+        </p:spPr>
+        <p:txBody>
+          <a:bodyPr wrap="square" lIns="45720" rIns="45720">
+            <a:spAutoFit/>
+          </a:bodyPr>
+          <a:lstStyle/>
+          <a:p>
+            <a:pPr algn="l"/>
+            <a:r>
+              <a:rPr sz="900" b="0">
+                <a:solidFill>
+                  <a:srgbClr val="64748B"/>
+                </a:solidFill>
+                <a:latin typeface="Segoe UI"/>
+              </a:rPr>
+              <a:t>Interfaz gráfica de escritorio</a:t>
+            </a:r>
+          </a:p>
+        </p:txBody>
+      </p:sp>
+      <p:sp>
+        <p:nvSpPr>
+          <p:cNvPr id="17" name="TextBox 16"/>
+          <p:cNvSpPr txBox="1"/>
+          <p:nvPr/>
+        </p:nvSpPr>
+        <p:spPr>
+          <a:xfrm>
+            <a:off x="822960" y="4480560"/>
+            <a:ext cx="1554480" cy="365760"/>
+          </a:xfrm>
+          <a:prstGeom prst="rect">
+            <a:avLst/>
+          </a:prstGeom>
+          <a:noFill/>
+        </p:spPr>
+        <p:txBody>
+          <a:bodyPr wrap="square" lIns="45720" rIns="45720">
+            <a:spAutoFit/>
+          </a:bodyPr>
+          <a:lstStyle/>
+          <a:p>
+            <a:pPr algn="l"/>
+            <a:r>
+              <a:rPr sz="1000" b="1">
+                <a:solidFill>
+                  <a:srgbClr val="0F172A"/>
+                </a:solidFill>
+                <a:latin typeface="Segoe UI"/>
+              </a:rPr>
+              <a:t>● HTML5 + JS</a:t>
+            </a:r>
+          </a:p>
+        </p:txBody>
+      </p:sp>
+      <p:sp>
+        <p:nvSpPr>
+          <p:cNvPr id="18" name="TextBox 17"/>
+          <p:cNvSpPr txBox="1"/>
+          <p:nvPr/>
+        </p:nvSpPr>
+        <p:spPr>
+          <a:xfrm>
+            <a:off x="2377440" y="4480560"/>
+            <a:ext cx="3840480" cy="365760"/>
+          </a:xfrm>
+          <a:prstGeom prst="rect">
+            <a:avLst/>
+          </a:prstGeom>
+          <a:noFill/>
+        </p:spPr>
+        <p:txBody>
+          <a:bodyPr wrap="square" lIns="45720" rIns="45720">
+            <a:spAutoFit/>
+          </a:bodyPr>
+          <a:lstStyle/>
+          <a:p>
+            <a:pPr algn="l"/>
+            <a:r>
+              <a:rPr sz="900" b="0">
+                <a:solidFill>
+                  <a:srgbClr val="64748B"/>
+                </a:solidFill>
+                <a:latin typeface="Segoe UI"/>
+              </a:rPr>
+              <a:t>Versión web responsiva (funciona en celular)</a:t>
+            </a:r>
+          </a:p>
+        </p:txBody>
+      </p:sp>
+      <p:sp>
+        <p:nvSpPr>
+          <p:cNvPr id="19" name="TextBox 18"/>
+          <p:cNvSpPr txBox="1"/>
+          <p:nvPr/>
+        </p:nvSpPr>
+        <p:spPr>
+          <a:xfrm>
+            <a:off x="6583680" y="1737360"/>
+            <a:ext cx="5029200" cy="365760"/>
+          </a:xfrm>
+          <a:prstGeom prst="rect">
+            <a:avLst/>
+          </a:prstGeom>
+          <a:noFill/>
+        </p:spPr>
+        <p:txBody>
+          <a:bodyPr wrap="square" lIns="45720" rIns="45720">
+            <a:spAutoFit/>
+          </a:bodyPr>
+          <a:lstStyle/>
+          <a:p>
+            <a:pPr algn="l"/>
+            <a:r>
+              <a:rPr sz="1400" b="1">
+                <a:solidFill>
+                  <a:srgbClr val="10B981"/>
+                </a:solidFill>
+                <a:latin typeface="Segoe UI"/>
+              </a:rPr>
+              <a:t>⭐ Valor agregado</a:t>
+            </a:r>
+          </a:p>
+        </p:txBody>
+      </p:sp>
+      <p:sp>
+        <p:nvSpPr>
+          <p:cNvPr id="20" name="TextBox 19"/>
+          <p:cNvSpPr txBox="1"/>
+          <p:nvPr/>
+        </p:nvSpPr>
+        <p:spPr>
+          <a:xfrm>
+            <a:off x="6583680" y="2194560"/>
+            <a:ext cx="365760" cy="365760"/>
+          </a:xfrm>
+          <a:prstGeom prst="rect">
+            <a:avLst/>
+          </a:prstGeom>
+          <a:noFill/>
+        </p:spPr>
+        <p:txBody>
+          <a:bodyPr wrap="square" lIns="45720" rIns="45720">
+            <a:spAutoFit/>
+          </a:bodyPr>
+          <a:lstStyle/>
+          <a:p>
+            <a:pPr algn="l"/>
+            <a:r>
+              <a:rPr sz="1600" b="1">
+                <a:solidFill>
+                  <a:srgbClr val="10B981"/>
+                </a:solidFill>
+                <a:latin typeface="Segoe UI"/>
+              </a:rPr>
+              <a:t>✓</a:t>
+            </a:r>
+          </a:p>
+        </p:txBody>
+      </p:sp>
+      <p:sp>
+        <p:nvSpPr>
+          <p:cNvPr id="21" name="TextBox 20"/>
+          <p:cNvSpPr txBox="1"/>
+          <p:nvPr/>
+        </p:nvSpPr>
+        <p:spPr>
+          <a:xfrm>
+            <a:off x="6949440" y="2194560"/>
+            <a:ext cx="4754880" cy="365760"/>
+          </a:xfrm>
+          <a:prstGeom prst="rect">
+            <a:avLst/>
+          </a:prstGeom>
+          <a:noFill/>
+        </p:spPr>
+        <p:txBody>
+          <a:bodyPr wrap="square" lIns="45720" rIns="45720">
+            <a:spAutoFit/>
+          </a:bodyPr>
+          <a:lstStyle/>
+          <a:p>
+            <a:pPr algn="l"/>
+            <a:r>
+              <a:rPr sz="1100" b="1">
+                <a:solidFill>
+                  <a:srgbClr val="0F172A"/>
+                </a:solidFill>
+                <a:latin typeface="Segoe UI"/>
+              </a:rPr>
+              <a:t>IA aplicada a detección</a:t>
+            </a:r>
+          </a:p>
+        </p:txBody>
+      </p:sp>
+      <p:sp>
+        <p:nvSpPr>
+          <p:cNvPr id="22" name="TextBox 21"/>
+          <p:cNvSpPr txBox="1"/>
+          <p:nvPr/>
+        </p:nvSpPr>
+        <p:spPr>
+          <a:xfrm>
+            <a:off x="6949440" y="2560320"/>
+            <a:ext cx="4754880" cy="822960"/>
+          </a:xfrm>
+          <a:prstGeom prst="rect">
+            <a:avLst/>
+          </a:prstGeom>
+          <a:noFill/>
+        </p:spPr>
+        <p:txBody>
+          <a:bodyPr wrap="square" lIns="45720" rIns="45720">
+            <a:spAutoFit/>
+          </a:bodyPr>
+          <a:lstStyle/>
+          <a:p>
+            <a:pPr algn="l"/>
+            <a:r>
+              <a:rPr sz="900" b="0">
+                <a:solidFill>
+                  <a:srgbClr val="64748B"/>
+                </a:solidFill>
+                <a:latin typeface="Segoe UI"/>
+              </a:rPr>
+              <a:t>Algoritmo de lock-on con tolerancia HSV adaptativa que sigue UN
+objeto específico, ignorando otros del mismo color</a:t>
+            </a:r>
+          </a:p>
+        </p:txBody>
+      </p:sp>
+      <p:sp>
+        <p:nvSpPr>
+          <p:cNvPr id="23" name="TextBox 22"/>
+          <p:cNvSpPr txBox="1"/>
+          <p:nvPr/>
+        </p:nvSpPr>
+        <p:spPr>
+          <a:xfrm>
+            <a:off x="6583680" y="3474720"/>
+            <a:ext cx="365760" cy="365760"/>
+          </a:xfrm>
+          <a:prstGeom prst="rect">
+            <a:avLst/>
+          </a:prstGeom>
+          <a:noFill/>
+        </p:spPr>
+        <p:txBody>
+          <a:bodyPr wrap="square" lIns="45720" rIns="45720">
+            <a:spAutoFit/>
+          </a:bodyPr>
+          <a:lstStyle/>
+          <a:p>
+            <a:pPr algn="l"/>
+            <a:r>
+              <a:rPr sz="1600" b="1">
+                <a:solidFill>
+                  <a:srgbClr val="10B981"/>
+                </a:solidFill>
+                <a:latin typeface="Segoe UI"/>
+              </a:rPr>
+              <a:t>✓</a:t>
+            </a:r>
+          </a:p>
+        </p:txBody>
+      </p:sp>
+      <p:sp>
+        <p:nvSpPr>
+          <p:cNvPr id="24" name="TextBox 23"/>
+          <p:cNvSpPr txBox="1"/>
+          <p:nvPr/>
+        </p:nvSpPr>
+        <p:spPr>
+          <a:xfrm>
+            <a:off x="6949440" y="3474720"/>
+            <a:ext cx="4754880" cy="365760"/>
+          </a:xfrm>
+          <a:prstGeom prst="rect">
+            <a:avLst/>
+          </a:prstGeom>
+          <a:noFill/>
+        </p:spPr>
+        <p:txBody>
+          <a:bodyPr wrap="square" lIns="45720" rIns="45720">
+            <a:spAutoFit/>
+          </a:bodyPr>
+          <a:lstStyle/>
+          <a:p>
+            <a:pPr algn="l"/>
+            <a:r>
+              <a:rPr sz="1100" b="1">
+                <a:solidFill>
+                  <a:srgbClr val="0F172A"/>
+                </a:solidFill>
+                <a:latin typeface="Segoe UI"/>
+              </a:rPr>
+              <a:t>Reconocimiento automático</a:t>
+            </a:r>
+          </a:p>
+        </p:txBody>
+      </p:sp>
+      <p:sp>
+        <p:nvSpPr>
+          <p:cNvPr id="25" name="TextBox 24"/>
+          <p:cNvSpPr txBox="1"/>
+          <p:nvPr/>
+        </p:nvSpPr>
+        <p:spPr>
+          <a:xfrm>
+            <a:off x="6949440" y="3840480"/>
+            <a:ext cx="4754880" cy="822960"/>
+          </a:xfrm>
+          <a:prstGeom prst="rect">
+            <a:avLst/>
+          </a:prstGeom>
+          <a:noFill/>
+        </p:spPr>
+        <p:txBody>
+          <a:bodyPr wrap="square" lIns="45720" rIns="45720">
+            <a:spAutoFit/>
+          </a:bodyPr>
+          <a:lstStyle/>
+          <a:p>
+            <a:pPr algn="l"/>
+            <a:r>
+              <a:rPr sz="900" b="0">
+                <a:solidFill>
+                  <a:srgbClr val="64748B"/>
+                </a:solidFill>
+                <a:latin typeface="Segoe UI"/>
+              </a:rPr>
+              <a:t>Clasifica solo si el movimiento es MRU, MRUV o Caída Libre
+según el promedio de aceleración medida</a:t>
+            </a:r>
+          </a:p>
+        </p:txBody>
+      </p:sp>
+      <p:sp>
+        <p:nvSpPr>
+          <p:cNvPr id="26" name="TextBox 25"/>
+          <p:cNvSpPr txBox="1"/>
+          <p:nvPr/>
+        </p:nvSpPr>
+        <p:spPr>
+          <a:xfrm>
+            <a:off x="6583680" y="4754879"/>
+            <a:ext cx="365760" cy="365760"/>
+          </a:xfrm>
+          <a:prstGeom prst="rect">
+            <a:avLst/>
+          </a:prstGeom>
+          <a:noFill/>
+        </p:spPr>
+        <p:txBody>
+          <a:bodyPr wrap="square" lIns="45720" rIns="45720">
+            <a:spAutoFit/>
+          </a:bodyPr>
+          <a:lstStyle/>
+          <a:p>
+            <a:pPr algn="l"/>
+            <a:r>
+              <a:rPr sz="1600" b="1">
+                <a:solidFill>
+                  <a:srgbClr val="10B981"/>
+                </a:solidFill>
+                <a:latin typeface="Segoe UI"/>
+              </a:rPr>
+              <a:t>✓</a:t>
+            </a:r>
+          </a:p>
+        </p:txBody>
+      </p:sp>
+      <p:sp>
+        <p:nvSpPr>
+          <p:cNvPr id="27" name="TextBox 26"/>
+          <p:cNvSpPr txBox="1"/>
+          <p:nvPr/>
+        </p:nvSpPr>
+        <p:spPr>
+          <a:xfrm>
+            <a:off x="6949440" y="4754879"/>
+            <a:ext cx="4754880" cy="365760"/>
+          </a:xfrm>
+          <a:prstGeom prst="rect">
+            <a:avLst/>
+          </a:prstGeom>
+          <a:noFill/>
+        </p:spPr>
+        <p:txBody>
+          <a:bodyPr wrap="square" lIns="45720" rIns="45720">
+            <a:spAutoFit/>
+          </a:bodyPr>
+          <a:lstStyle/>
+          <a:p>
+            <a:pPr algn="l"/>
+            <a:r>
+              <a:rPr sz="1100" b="1">
+                <a:solidFill>
+                  <a:srgbClr val="0F172A"/>
+                </a:solidFill>
+                <a:latin typeface="Segoe UI"/>
+              </a:rPr>
+              <a:t>Aplicación multiplataforma</a:t>
+            </a:r>
+          </a:p>
+        </p:txBody>
+      </p:sp>
+      <p:sp>
+        <p:nvSpPr>
+          <p:cNvPr id="28" name="TextBox 27"/>
+          <p:cNvSpPr txBox="1"/>
+          <p:nvPr/>
+        </p:nvSpPr>
+        <p:spPr>
+          <a:xfrm>
+            <a:off x="6949440" y="5120639"/>
+            <a:ext cx="4754880" cy="822960"/>
+          </a:xfrm>
+          <a:prstGeom prst="rect">
+            <a:avLst/>
+          </a:prstGeom>
+          <a:noFill/>
+        </p:spPr>
+        <p:txBody>
+          <a:bodyPr wrap="square" lIns="45720" rIns="45720">
+            <a:spAutoFit/>
+          </a:bodyPr>
+          <a:lstStyle/>
+          <a:p>
+            <a:pPr algn="l"/>
+            <a:r>
+              <a:rPr sz="900" b="0">
+                <a:solidFill>
+                  <a:srgbClr val="64748B"/>
+                </a:solidFill>
+                <a:latin typeface="Segoe UI"/>
+              </a:rPr>
+              <a:t>Versión escritorio (Python) + versión web (cualquier celular,
+sin instalar nada, accesible por QR)</a:t>
+            </a:r>
+          </a:p>
+        </p:txBody>
+      </p:sp>
+    </p:spTree>
+  </p:cSld>
+  <p:clrMapOvr>
+    <a:masterClrMapping/>
+  </p:clrMapOvr>
+</p:sld>
+</file>
+
+<file path=ppt/slides/slide5.xml><?xml version="1.0" encoding="utf-8"?>
+<p:sld xmlns:a="http://schemas.openxmlformats.org/drawingml/2006/main" xmlns:p="http://schemas.openxmlformats.org/presentationml/2006/main" xmlns:r="http://schemas.openxmlformats.org/officeDocument/2006/relationships">
+  <p:cSld>
+    <p:spTree>
+      <p:nvGrpSpPr>
+        <p:cNvPr id="1" name=""/>
+        <p:cNvGrpSpPr/>
+        <p:nvPr/>
+      </p:nvGrpSpPr>
+      <p:grpSpPr/>
+      <p:sp>
+        <p:nvSpPr>
+          <p:cNvPr id="2" name="Rectangle 1"/>
+          <p:cNvSpPr/>
+          <p:nvPr/>
+        </p:nvSpPr>
+        <p:spPr>
+          <a:xfrm>
+            <a:off x="0" y="0"/>
+            <a:ext cx="12188952" cy="6858000"/>
+          </a:xfrm>
+          <a:prstGeom prst="rect">
+            <a:avLst/>
+          </a:prstGeom>
+          <a:solidFill>
+            <a:srgbClr val="FFFFFF"/>
+          </a:solidFill>
+          <a:ln>
+            <a:noFill/>
+          </a:ln>
+          <a:effectLst/>
+        </p:spPr>
+        <p:style>
+          <a:lnRef idx="1">
+            <a:schemeClr val="accent1"/>
+          </a:lnRef>
+          <a:fillRef idx="3">
+            <a:schemeClr val="accent1"/>
+          </a:fillRef>
+          <a:effectRef idx="2">
+            <a:schemeClr val="accent1"/>
+          </a:effectRef>
+          <a:fontRef idx="minor">
+            <a:schemeClr val="lt1"/>
+          </a:fontRef>
+        </p:style>
+        <p:txBody>
+          <a:bodyPr rtlCol="0" anchor="ctr"/>
+          <a:lstStyle/>
+          <a:p>
+            <a:pPr algn="ctr"/>
+          </a:p>
+        </p:txBody>
+      </p:sp>
+      <p:sp>
+        <p:nvSpPr>
+          <p:cNvPr id="3" name="Rectangle 2"/>
+          <p:cNvSpPr/>
+          <p:nvPr/>
+        </p:nvSpPr>
+        <p:spPr>
+          <a:xfrm>
+            <a:off x="0" y="0"/>
+            <a:ext cx="12188952" cy="640080"/>
+          </a:xfrm>
+          <a:prstGeom prst="rect">
+            <a:avLst/>
+          </a:prstGeom>
+          <a:solidFill>
+            <a:srgbClr val="0F172A"/>
+          </a:solidFill>
+          <a:ln>
+            <a:noFill/>
+          </a:ln>
+          <a:effectLst/>
+        </p:spPr>
+        <p:style>
+          <a:lnRef idx="1">
+            <a:schemeClr val="accent1"/>
+          </a:lnRef>
+          <a:fillRef idx="3">
+            <a:schemeClr val="accent1"/>
+          </a:fillRef>
+          <a:effectRef idx="2">
+            <a:schemeClr val="accent1"/>
+          </a:effectRef>
+          <a:fontRef idx="minor">
+            <a:schemeClr val="lt1"/>
+          </a:fontRef>
+        </p:style>
+        <p:txBody>
+          <a:bodyPr rtlCol="0" anchor="ctr"/>
+          <a:lstStyle/>
+          <a:p>
+            <a:pPr algn="ctr"/>
+          </a:p>
+        </p:txBody>
+      </p:sp>
+      <p:sp>
+        <p:nvSpPr>
+          <p:cNvPr id="4" name="TextBox 3"/>
+          <p:cNvSpPr txBox="1"/>
+          <p:nvPr/>
+        </p:nvSpPr>
+        <p:spPr>
+          <a:xfrm>
+            <a:off x="457200" y="137160"/>
+            <a:ext cx="10972800" cy="411480"/>
+          </a:xfrm>
+          <a:prstGeom prst="rect">
+            <a:avLst/>
+          </a:prstGeom>
+          <a:noFill/>
+        </p:spPr>
+        <p:txBody>
+          <a:bodyPr wrap="square" lIns="45720" rIns="45720">
+            <a:spAutoFit/>
+          </a:bodyPr>
+          <a:lstStyle/>
+          <a:p>
+            <a:pPr algn="l"/>
+            <a:r>
+              <a:rPr sz="1800" b="1">
+                <a:solidFill>
+                  <a:srgbClr val="FFFFFF"/>
+                </a:solidFill>
+                <a:latin typeface="Segoe UI"/>
+              </a:rPr>
+              <a:t>LÓGICA FÍSICA + CÓMO FUNCIONA EL CÓDIGO</a:t>
+            </a:r>
+          </a:p>
+        </p:txBody>
+      </p:sp>
+      <p:sp>
+        <p:nvSpPr>
+          <p:cNvPr id="5" name="TextBox 4"/>
+          <p:cNvSpPr txBox="1"/>
+          <p:nvPr/>
+        </p:nvSpPr>
+        <p:spPr>
+          <a:xfrm>
+            <a:off x="548640" y="868680"/>
+            <a:ext cx="10972800" cy="457200"/>
+          </a:xfrm>
+          <a:prstGeom prst="rect">
+            <a:avLst/>
+          </a:prstGeom>
+          <a:noFill/>
+        </p:spPr>
+        <p:txBody>
+          <a:bodyPr wrap="square" lIns="45720" rIns="45720">
+            <a:spAutoFit/>
+          </a:bodyPr>
+          <a:lstStyle/>
+          <a:p>
+            <a:pPr algn="l"/>
+            <a:r>
+              <a:rPr sz="1800" b="1">
+                <a:solidFill>
+                  <a:srgbClr val="0F172A"/>
+                </a:solidFill>
+                <a:latin typeface="Segoe UI"/>
+              </a:rPr>
+              <a:t>Del píxel detectado a la variable física</a:t>
+            </a:r>
+          </a:p>
+        </p:txBody>
+      </p:sp>
+      <p:sp>
+        <p:nvSpPr>
+          <p:cNvPr id="6" name="TextBox 5"/>
+          <p:cNvSpPr txBox="1"/>
+          <p:nvPr/>
+        </p:nvSpPr>
+        <p:spPr>
+          <a:xfrm>
+            <a:off x="548640" y="1508760"/>
+            <a:ext cx="5486400" cy="365760"/>
+          </a:xfrm>
+          <a:prstGeom prst="rect">
+            <a:avLst/>
+          </a:prstGeom>
+          <a:noFill/>
+        </p:spPr>
+        <p:txBody>
+          <a:bodyPr wrap="square" lIns="45720" rIns="45720">
+            <a:spAutoFit/>
+          </a:bodyPr>
+          <a:lstStyle/>
+          <a:p>
+            <a:pPr algn="l"/>
+            <a:r>
+              <a:rPr sz="1300" b="1">
+                <a:solidFill>
+                  <a:srgbClr val="2563EB"/>
+                </a:solidFill>
+                <a:latin typeface="Segoe UI"/>
+              </a:rPr>
+              <a:t>🎯  Cómo medimos cada variable</a:t>
+            </a:r>
+          </a:p>
+        </p:txBody>
+      </p:sp>
+      <p:sp>
+        <p:nvSpPr>
+          <p:cNvPr id="7" name="Rounded Rectangle 6"/>
+          <p:cNvSpPr/>
+          <p:nvPr/>
+        </p:nvSpPr>
+        <p:spPr>
+          <a:xfrm>
+            <a:off x="548640" y="1920240"/>
+            <a:ext cx="5486400" cy="1188720"/>
+          </a:xfrm>
+          <a:prstGeom prst="roundRect">
+            <a:avLst/>
+          </a:prstGeom>
+          <a:solidFill>
+            <a:srgbClr val="F8FAFC"/>
+          </a:solidFill>
+          <a:ln w="19050">
+            <a:solidFill>
+              <a:srgbClr val="2563EB"/>
+            </a:solidFill>
+          </a:ln>
+          <a:effectLst/>
+        </p:spPr>
+        <p:style>
+          <a:lnRef idx="1">
+            <a:schemeClr val="accent1"/>
+          </a:lnRef>
+          <a:fillRef idx="3">
+            <a:schemeClr val="accent1"/>
+          </a:fillRef>
+          <a:effectRef idx="2">
+            <a:schemeClr val="accent1"/>
+          </a:effectRef>
+          <a:fontRef idx="minor">
+            <a:schemeClr val="lt1"/>
+          </a:fontRef>
+        </p:style>
+        <p:txBody>
+          <a:bodyPr rtlCol="0" anchor="ctr"/>
+          <a:lstStyle/>
+          <a:p>
+            <a:pPr algn="ctr"/>
+          </a:p>
+        </p:txBody>
+      </p:sp>
+      <p:sp>
+        <p:nvSpPr>
+          <p:cNvPr id="8" name="TextBox 7"/>
+          <p:cNvSpPr txBox="1"/>
+          <p:nvPr/>
+        </p:nvSpPr>
+        <p:spPr>
+          <a:xfrm>
+            <a:off x="731520" y="2011680"/>
+            <a:ext cx="5120640" cy="365760"/>
+          </a:xfrm>
+          <a:prstGeom prst="rect">
+            <a:avLst/>
+          </a:prstGeom>
+          <a:noFill/>
+        </p:spPr>
+        <p:txBody>
+          <a:bodyPr wrap="square" lIns="45720" rIns="45720">
+            <a:spAutoFit/>
+          </a:bodyPr>
+          <a:lstStyle/>
+          <a:p>
+            <a:pPr algn="l"/>
+            <a:r>
+              <a:rPr sz="1100" b="1">
+                <a:solidFill>
+                  <a:srgbClr val="2563EB"/>
+                </a:solidFill>
+                <a:latin typeface="Segoe UI"/>
+              </a:rPr>
+              <a:t>1. POSICIÓN</a:t>
+            </a:r>
+          </a:p>
+        </p:txBody>
+      </p:sp>
+      <p:sp>
+        <p:nvSpPr>
+          <p:cNvPr id="9" name="TextBox 8"/>
+          <p:cNvSpPr txBox="1"/>
+          <p:nvPr/>
+        </p:nvSpPr>
+        <p:spPr>
+          <a:xfrm>
+            <a:off x="731520" y="2331720"/>
+            <a:ext cx="5120640" cy="777240"/>
+          </a:xfrm>
+          <a:prstGeom prst="rect">
+            <a:avLst/>
+          </a:prstGeom>
+          <a:noFill/>
+        </p:spPr>
+        <p:txBody>
+          <a:bodyPr wrap="square" lIns="45720" rIns="45720">
+            <a:spAutoFit/>
+          </a:bodyPr>
+          <a:lstStyle/>
+          <a:p>
+            <a:pPr algn="l"/>
+            <a:r>
+              <a:rPr sz="900" b="0">
+                <a:solidFill>
+                  <a:srgbClr val="0F172A"/>
+                </a:solidFill>
+                <a:latin typeface="Consolas"/>
+              </a:rPr>
+              <a:t>OpenCV calcula el centroide (cx, cy) del contorno detectado:
+    cx = M10 / M00,   cy = M01 / M00
+Luego se convierte de píxeles a metros usando la calibración.</a:t>
+            </a:r>
+          </a:p>
+        </p:txBody>
+      </p:sp>
+      <p:sp>
+        <p:nvSpPr>
+          <p:cNvPr id="10" name="Rounded Rectangle 9"/>
+          <p:cNvSpPr/>
+          <p:nvPr/>
+        </p:nvSpPr>
+        <p:spPr>
+          <a:xfrm>
+            <a:off x="548640" y="3291840"/>
+            <a:ext cx="5486400" cy="1188720"/>
+          </a:xfrm>
+          <a:prstGeom prst="roundRect">
+            <a:avLst/>
+          </a:prstGeom>
+          <a:solidFill>
+            <a:srgbClr val="F8FAFC"/>
+          </a:solidFill>
+          <a:ln w="19050">
+            <a:solidFill>
+              <a:srgbClr val="2563EB"/>
+            </a:solidFill>
+          </a:ln>
+          <a:effectLst/>
+        </p:spPr>
+        <p:style>
+          <a:lnRef idx="1">
+            <a:schemeClr val="accent1"/>
+          </a:lnRef>
+          <a:fillRef idx="3">
+            <a:schemeClr val="accent1"/>
+          </a:fillRef>
+          <a:effectRef idx="2">
+            <a:schemeClr val="accent1"/>
+          </a:effectRef>
+          <a:fontRef idx="minor">
+            <a:schemeClr val="lt1"/>
+          </a:fontRef>
+        </p:style>
+        <p:txBody>
+          <a:bodyPr rtlCol="0" anchor="ctr"/>
+          <a:lstStyle/>
+          <a:p>
+            <a:pPr algn="ctr"/>
+          </a:p>
+        </p:txBody>
+      </p:sp>
+      <p:sp>
+        <p:nvSpPr>
+          <p:cNvPr id="11" name="TextBox 10"/>
+          <p:cNvSpPr txBox="1"/>
+          <p:nvPr/>
+        </p:nvSpPr>
+        <p:spPr>
+          <a:xfrm>
+            <a:off x="731520" y="3383280"/>
+            <a:ext cx="5120640" cy="365760"/>
+          </a:xfrm>
+          <a:prstGeom prst="rect">
+            <a:avLst/>
+          </a:prstGeom>
+          <a:noFill/>
+        </p:spPr>
+        <p:txBody>
+          <a:bodyPr wrap="square" lIns="45720" rIns="45720">
+            <a:spAutoFit/>
+          </a:bodyPr>
+          <a:lstStyle/>
+          <a:p>
+            <a:pPr algn="l"/>
+            <a:r>
+              <a:rPr sz="1100" b="1">
+                <a:solidFill>
+                  <a:srgbClr val="2563EB"/>
+                </a:solidFill>
+                <a:latin typeface="Segoe UI"/>
+              </a:rPr>
+              <a:t>2. VELOCIDAD</a:t>
+            </a:r>
+          </a:p>
+        </p:txBody>
+      </p:sp>
+      <p:sp>
+        <p:nvSpPr>
+          <p:cNvPr id="12" name="TextBox 11"/>
+          <p:cNvSpPr txBox="1"/>
+          <p:nvPr/>
+        </p:nvSpPr>
+        <p:spPr>
+          <a:xfrm>
+            <a:off x="731520" y="3703320"/>
+            <a:ext cx="5120640" cy="777240"/>
+          </a:xfrm>
+          <a:prstGeom prst="rect">
+            <a:avLst/>
+          </a:prstGeom>
+          <a:noFill/>
+        </p:spPr>
+        <p:txBody>
+          <a:bodyPr wrap="square" lIns="45720" rIns="45720">
+            <a:spAutoFit/>
+          </a:bodyPr>
+          <a:lstStyle/>
+          <a:p>
+            <a:pPr algn="l"/>
+            <a:r>
+              <a:rPr sz="900" b="0">
+                <a:solidFill>
+                  <a:srgbClr val="0F172A"/>
+                </a:solidFill>
+                <a:latin typeface="Consolas"/>
+              </a:rPr>
+              <a:t>Derivada numérica con diferencias finitas centrales:
+    v[i] = (x[i+1] − x[i−1]) / (t[i+1] − t[i−1])
+Más preciso que adelante/atrás.</a:t>
+            </a:r>
+          </a:p>
+        </p:txBody>
+      </p:sp>
+      <p:sp>
+        <p:nvSpPr>
+          <p:cNvPr id="13" name="Rounded Rectangle 12"/>
+          <p:cNvSpPr/>
+          <p:nvPr/>
+        </p:nvSpPr>
+        <p:spPr>
+          <a:xfrm>
+            <a:off x="548640" y="4663440"/>
+            <a:ext cx="5486400" cy="1188720"/>
+          </a:xfrm>
+          <a:prstGeom prst="roundRect">
+            <a:avLst/>
+          </a:prstGeom>
+          <a:solidFill>
+            <a:srgbClr val="F8FAFC"/>
+          </a:solidFill>
+          <a:ln w="19050">
+            <a:solidFill>
+              <a:srgbClr val="2563EB"/>
+            </a:solidFill>
+          </a:ln>
+          <a:effectLst/>
+        </p:spPr>
+        <p:style>
+          <a:lnRef idx="1">
+            <a:schemeClr val="accent1"/>
+          </a:lnRef>
+          <a:fillRef idx="3">
+            <a:schemeClr val="accent1"/>
+          </a:fillRef>
+          <a:effectRef idx="2">
+            <a:schemeClr val="accent1"/>
+          </a:effectRef>
+          <a:fontRef idx="minor">
+            <a:schemeClr val="lt1"/>
+          </a:fontRef>
+        </p:style>
+        <p:txBody>
+          <a:bodyPr rtlCol="0" anchor="ctr"/>
+          <a:lstStyle/>
+          <a:p>
+            <a:pPr algn="ctr"/>
+          </a:p>
+        </p:txBody>
+      </p:sp>
+      <p:sp>
+        <p:nvSpPr>
+          <p:cNvPr id="14" name="TextBox 13"/>
+          <p:cNvSpPr txBox="1"/>
+          <p:nvPr/>
+        </p:nvSpPr>
+        <p:spPr>
+          <a:xfrm>
+            <a:off x="731520" y="4754880"/>
+            <a:ext cx="5120640" cy="365760"/>
+          </a:xfrm>
+          <a:prstGeom prst="rect">
+            <a:avLst/>
+          </a:prstGeom>
+          <a:noFill/>
+        </p:spPr>
+        <p:txBody>
+          <a:bodyPr wrap="square" lIns="45720" rIns="45720">
+            <a:spAutoFit/>
+          </a:bodyPr>
+          <a:lstStyle/>
+          <a:p>
+            <a:pPr algn="l"/>
+            <a:r>
+              <a:rPr sz="1100" b="1">
+                <a:solidFill>
+                  <a:srgbClr val="2563EB"/>
+                </a:solidFill>
+                <a:latin typeface="Segoe UI"/>
+              </a:rPr>
+              <a:t>3. ACELERACIÓN</a:t>
+            </a:r>
+          </a:p>
+        </p:txBody>
+      </p:sp>
+      <p:sp>
+        <p:nvSpPr>
+          <p:cNvPr id="15" name="TextBox 14"/>
+          <p:cNvSpPr txBox="1"/>
+          <p:nvPr/>
+        </p:nvSpPr>
+        <p:spPr>
+          <a:xfrm>
+            <a:off x="731520" y="5074920"/>
+            <a:ext cx="5120640" cy="777240"/>
+          </a:xfrm>
+          <a:prstGeom prst="rect">
+            <a:avLst/>
+          </a:prstGeom>
+          <a:noFill/>
+        </p:spPr>
+        <p:txBody>
+          <a:bodyPr wrap="square" lIns="45720" rIns="45720">
+            <a:spAutoFit/>
+          </a:bodyPr>
+          <a:lstStyle/>
+          <a:p>
+            <a:pPr algn="l"/>
+            <a:r>
+              <a:rPr sz="900" b="0">
+                <a:solidFill>
+                  <a:srgbClr val="0F172A"/>
+                </a:solidFill>
+                <a:latin typeface="Consolas"/>
+              </a:rPr>
+              <a:t>Segunda derivada central:
+    a[i] = (x[i+1] − 2·x[i] + x[i−1]) / Δt²
+Filtro Savitzky-Golay para reducir ruido.</a:t>
+            </a:r>
+          </a:p>
+        </p:txBody>
+      </p:sp>
+      <p:sp>
+        <p:nvSpPr>
+          <p:cNvPr id="16" name="TextBox 15"/>
+          <p:cNvSpPr txBox="1"/>
+          <p:nvPr/>
+        </p:nvSpPr>
+        <p:spPr>
+          <a:xfrm>
+            <a:off x="6400800" y="1508760"/>
+            <a:ext cx="5486400" cy="365760"/>
+          </a:xfrm>
+          <a:prstGeom prst="rect">
+            <a:avLst/>
+          </a:prstGeom>
+          <a:noFill/>
+        </p:spPr>
+        <p:txBody>
+          <a:bodyPr wrap="square" lIns="45720" rIns="45720">
+            <a:spAutoFit/>
+          </a:bodyPr>
+          <a:lstStyle/>
+          <a:p>
+            <a:pPr algn="l"/>
+            <a:r>
+              <a:rPr sz="1300" b="1">
+                <a:solidFill>
+                  <a:srgbClr val="10B981"/>
+                </a:solidFill>
+                <a:latin typeface="Segoe UI"/>
+              </a:rPr>
+              <a:t>📐  Ecuaciones por tipo de movimiento</a:t>
+            </a:r>
+          </a:p>
+        </p:txBody>
+      </p:sp>
+      <p:sp>
+        <p:nvSpPr>
+          <p:cNvPr id="17" name="Rounded Rectangle 16"/>
+          <p:cNvSpPr/>
+          <p:nvPr/>
+        </p:nvSpPr>
+        <p:spPr>
+          <a:xfrm>
+            <a:off x="6400800" y="1920240"/>
+            <a:ext cx="5303520" cy="1188720"/>
+          </a:xfrm>
+          <a:prstGeom prst="roundRect">
+            <a:avLst/>
+          </a:prstGeom>
+          <a:solidFill>
+            <a:srgbClr val="F8FAFC"/>
+          </a:solidFill>
+          <a:ln w="19050">
+            <a:solidFill>
+              <a:srgbClr val="10B981"/>
+            </a:solidFill>
+          </a:ln>
+          <a:effectLst/>
+        </p:spPr>
+        <p:style>
+          <a:lnRef idx="1">
+            <a:schemeClr val="accent1"/>
+          </a:lnRef>
+          <a:fillRef idx="3">
+            <a:schemeClr val="accent1"/>
+          </a:fillRef>
+          <a:effectRef idx="2">
+            <a:schemeClr val="accent1"/>
+          </a:effectRef>
+          <a:fontRef idx="minor">
+            <a:schemeClr val="lt1"/>
+          </a:fontRef>
+        </p:style>
+        <p:txBody>
+          <a:bodyPr rtlCol="0" anchor="ctr"/>
+          <a:lstStyle/>
+          <a:p>
+            <a:pPr algn="ctr"/>
+          </a:p>
+        </p:txBody>
+      </p:sp>
+      <p:sp>
+        <p:nvSpPr>
+          <p:cNvPr id="18" name="TextBox 17"/>
+          <p:cNvSpPr txBox="1"/>
+          <p:nvPr/>
+        </p:nvSpPr>
+        <p:spPr>
+          <a:xfrm>
+            <a:off x="6583680" y="2011680"/>
+            <a:ext cx="4937760" cy="365760"/>
+          </a:xfrm>
+          <a:prstGeom prst="rect">
+            <a:avLst/>
+          </a:prstGeom>
+          <a:noFill/>
+        </p:spPr>
+        <p:txBody>
+          <a:bodyPr wrap="square" lIns="45720" rIns="45720">
+            <a:spAutoFit/>
+          </a:bodyPr>
+          <a:lstStyle/>
+          <a:p>
+            <a:pPr algn="l"/>
+            <a:r>
+              <a:rPr sz="1100" b="1">
+                <a:solidFill>
+                  <a:srgbClr val="10B981"/>
+                </a:solidFill>
+                <a:latin typeface="Segoe UI"/>
+              </a:rPr>
+              <a:t>MRU — Velocidad constante</a:t>
+            </a:r>
+          </a:p>
+        </p:txBody>
+      </p:sp>
+      <p:sp>
+        <p:nvSpPr>
+          <p:cNvPr id="19" name="TextBox 18"/>
+          <p:cNvSpPr txBox="1"/>
+          <p:nvPr/>
+        </p:nvSpPr>
+        <p:spPr>
+          <a:xfrm>
+            <a:off x="6583680" y="2331720"/>
+            <a:ext cx="4937760" cy="777240"/>
+          </a:xfrm>
+          <a:prstGeom prst="rect">
+            <a:avLst/>
+          </a:prstGeom>
+          <a:noFill/>
+        </p:spPr>
+        <p:txBody>
+          <a:bodyPr wrap="square" lIns="45720" rIns="45720">
+            <a:spAutoFit/>
+          </a:bodyPr>
+          <a:lstStyle/>
+          <a:p>
+            <a:pPr algn="l"/>
+            <a:r>
+              <a:rPr sz="900" b="0">
+                <a:solidFill>
+                  <a:srgbClr val="0F172A"/>
+                </a:solidFill>
+                <a:latin typeface="Consolas"/>
+              </a:rPr>
+              <a:t>x(t) = x₀ + v · t
+Se cumple cuando |ā| &lt; 0.5 m/s²
+(aceleración prácticamente nula)</a:t>
+            </a:r>
+          </a:p>
+        </p:txBody>
+      </p:sp>
+      <p:sp>
+        <p:nvSpPr>
+          <p:cNvPr id="20" name="Rounded Rectangle 19"/>
+          <p:cNvSpPr/>
+          <p:nvPr/>
+        </p:nvSpPr>
+        <p:spPr>
+          <a:xfrm>
+            <a:off x="6400800" y="3291840"/>
+            <a:ext cx="5303520" cy="1188720"/>
+          </a:xfrm>
+          <a:prstGeom prst="roundRect">
+            <a:avLst/>
+          </a:prstGeom>
+          <a:solidFill>
+            <a:srgbClr val="F8FAFC"/>
+          </a:solidFill>
+          <a:ln w="19050">
+            <a:solidFill>
+              <a:srgbClr val="F59E0B"/>
+            </a:solidFill>
+          </a:ln>
+          <a:effectLst/>
+        </p:spPr>
+        <p:style>
+          <a:lnRef idx="1">
+            <a:schemeClr val="accent1"/>
+          </a:lnRef>
+          <a:fillRef idx="3">
+            <a:schemeClr val="accent1"/>
+          </a:fillRef>
+          <a:effectRef idx="2">
+            <a:schemeClr val="accent1"/>
+          </a:effectRef>
+          <a:fontRef idx="minor">
+            <a:schemeClr val="lt1"/>
+          </a:fontRef>
+        </p:style>
+        <p:txBody>
+          <a:bodyPr rtlCol="0" anchor="ctr"/>
+          <a:lstStyle/>
+          <a:p>
+            <a:pPr algn="ctr"/>
+          </a:p>
+        </p:txBody>
+      </p:sp>
+      <p:sp>
+        <p:nvSpPr>
+          <p:cNvPr id="21" name="TextBox 20"/>
+          <p:cNvSpPr txBox="1"/>
+          <p:nvPr/>
+        </p:nvSpPr>
+        <p:spPr>
+          <a:xfrm>
+            <a:off x="6583680" y="3383280"/>
+            <a:ext cx="4937760" cy="365760"/>
+          </a:xfrm>
+          <a:prstGeom prst="rect">
+            <a:avLst/>
+          </a:prstGeom>
+          <a:noFill/>
+        </p:spPr>
+        <p:txBody>
+          <a:bodyPr wrap="square" lIns="45720" rIns="45720">
+            <a:spAutoFit/>
+          </a:bodyPr>
+          <a:lstStyle/>
+          <a:p>
+            <a:pPr algn="l"/>
+            <a:r>
+              <a:rPr sz="1100" b="1">
+                <a:solidFill>
+                  <a:srgbClr val="F59E0B"/>
+                </a:solidFill>
+                <a:latin typeface="Segoe UI"/>
+              </a:rPr>
+              <a:t>MRUV — Aceleración constante</a:t>
+            </a:r>
+          </a:p>
+        </p:txBody>
+      </p:sp>
+      <p:sp>
+        <p:nvSpPr>
+          <p:cNvPr id="22" name="TextBox 21"/>
+          <p:cNvSpPr txBox="1"/>
+          <p:nvPr/>
+        </p:nvSpPr>
+        <p:spPr>
+          <a:xfrm>
+            <a:off x="6583680" y="3703320"/>
+            <a:ext cx="4937760" cy="777240"/>
+          </a:xfrm>
+          <a:prstGeom prst="rect">
+            <a:avLst/>
+          </a:prstGeom>
+          <a:noFill/>
+        </p:spPr>
+        <p:txBody>
+          <a:bodyPr wrap="square" lIns="45720" rIns="45720">
+            <a:spAutoFit/>
+          </a:bodyPr>
+          <a:lstStyle/>
+          <a:p>
+            <a:pPr algn="l"/>
+            <a:r>
+              <a:rPr sz="900" b="0">
+                <a:solidFill>
+                  <a:srgbClr val="0F172A"/>
+                </a:solidFill>
+                <a:latin typeface="Consolas"/>
+              </a:rPr>
+              <a:t>x(t) = x₀ + v₀·t + ½·a·t²
+v(t) = v₀ + a·t
+Para cualquier aceleración constante</a:t>
+            </a:r>
+          </a:p>
+        </p:txBody>
+      </p:sp>
+      <p:sp>
+        <p:nvSpPr>
+          <p:cNvPr id="23" name="Rounded Rectangle 22"/>
+          <p:cNvSpPr/>
+          <p:nvPr/>
+        </p:nvSpPr>
+        <p:spPr>
+          <a:xfrm>
+            <a:off x="6400800" y="4663440"/>
+            <a:ext cx="5303520" cy="1188720"/>
+          </a:xfrm>
+          <a:prstGeom prst="roundRect">
+            <a:avLst/>
+          </a:prstGeom>
+          <a:solidFill>
+            <a:srgbClr val="F8FAFC"/>
+          </a:solidFill>
+          <a:ln w="19050">
+            <a:solidFill>
+              <a:srgbClr val="8B5CF6"/>
+            </a:solidFill>
+          </a:ln>
+          <a:effectLst/>
+        </p:spPr>
+        <p:style>
+          <a:lnRef idx="1">
+            <a:schemeClr val="accent1"/>
+          </a:lnRef>
+          <a:fillRef idx="3">
+            <a:schemeClr val="accent1"/>
+          </a:fillRef>
+          <a:effectRef idx="2">
+            <a:schemeClr val="accent1"/>
+          </a:effectRef>
+          <a:fontRef idx="minor">
+            <a:schemeClr val="lt1"/>
+          </a:fontRef>
+        </p:style>
+        <p:txBody>
+          <a:bodyPr rtlCol="0" anchor="ctr"/>
+          <a:lstStyle/>
+          <a:p>
+            <a:pPr algn="ctr"/>
+          </a:p>
+        </p:txBody>
+      </p:sp>
+      <p:sp>
+        <p:nvSpPr>
+          <p:cNvPr id="24" name="TextBox 23"/>
+          <p:cNvSpPr txBox="1"/>
+          <p:nvPr/>
+        </p:nvSpPr>
+        <p:spPr>
+          <a:xfrm>
+            <a:off x="6583680" y="4754880"/>
+            <a:ext cx="4937760" cy="365760"/>
+          </a:xfrm>
+          <a:prstGeom prst="rect">
+            <a:avLst/>
+          </a:prstGeom>
+          <a:noFill/>
+        </p:spPr>
+        <p:txBody>
+          <a:bodyPr wrap="square" lIns="45720" rIns="45720">
+            <a:spAutoFit/>
+          </a:bodyPr>
+          <a:lstStyle/>
+          <a:p>
+            <a:pPr algn="l"/>
+            <a:r>
+              <a:rPr sz="1100" b="1">
+                <a:solidFill>
+                  <a:srgbClr val="8B5CF6"/>
+                </a:solidFill>
+                <a:latin typeface="Segoe UI"/>
+              </a:rPr>
+              <a:t>Caída Libre — g = 9.8 m/s²</a:t>
+            </a:r>
+          </a:p>
+        </p:txBody>
+      </p:sp>
+      <p:sp>
+        <p:nvSpPr>
+          <p:cNvPr id="25" name="TextBox 24"/>
+          <p:cNvSpPr txBox="1"/>
+          <p:nvPr/>
+        </p:nvSpPr>
+        <p:spPr>
+          <a:xfrm>
+            <a:off x="6583680" y="5074920"/>
+            <a:ext cx="4937760" cy="777240"/>
+          </a:xfrm>
+          <a:prstGeom prst="rect">
+            <a:avLst/>
+          </a:prstGeom>
+          <a:noFill/>
+        </p:spPr>
+        <p:txBody>
+          <a:bodyPr wrap="square" lIns="45720" rIns="45720">
+            <a:spAutoFit/>
+          </a:bodyPr>
+          <a:lstStyle/>
+          <a:p>
+            <a:pPr algn="l"/>
+            <a:r>
+              <a:rPr sz="900" b="0">
+                <a:solidFill>
+                  <a:srgbClr val="0F172A"/>
+                </a:solidFill>
+                <a:latin typeface="Consolas"/>
+              </a:rPr>
+              <a:t>y(t) = y₀ + v₀·t − ½·g·t²
+Detectado si ||ā| − 9.8| &lt; 1.5 m/s²</a:t>
+            </a:r>
+          </a:p>
+        </p:txBody>
+      </p:sp>
+      <p:sp>
+        <p:nvSpPr>
+          <p:cNvPr id="26" name="TextBox 25"/>
+          <p:cNvSpPr txBox="1"/>
+          <p:nvPr/>
+        </p:nvSpPr>
+        <p:spPr>
+          <a:xfrm>
+            <a:off x="548640" y="6263640"/>
+            <a:ext cx="10972800" cy="365760"/>
+          </a:xfrm>
+          <a:prstGeom prst="rect">
+            <a:avLst/>
+          </a:prstGeom>
+          <a:noFill/>
+        </p:spPr>
+        <p:txBody>
+          <a:bodyPr wrap="square" lIns="45720" rIns="45720">
+            <a:spAutoFit/>
+          </a:bodyPr>
+          <a:lstStyle/>
+          <a:p>
+            <a:pPr algn="ctr"/>
+            <a:r>
+              <a:rPr sz="1000" b="1">
+                <a:solidFill>
+                  <a:srgbClr val="0F172A"/>
+                </a:solidFill>
+                <a:latin typeface="Segoe UI"/>
+              </a:rPr>
+              <a:t>🔍 Detección visual:  BGR → HSV → máscara binaria → contornos → centroide → lock-on al objeto</a:t>
+            </a:r>
+          </a:p>
+        </p:txBody>
+      </p:sp>
+    </p:spTree>
+  </p:cSld>
+  <p:clrMapOvr>
+    <a:masterClrMapping/>
+  </p:clrMapOvr>
+</p:sld>
+</file>
+
+<file path=ppt/slides/slide6.xml><?xml version="1.0" encoding="utf-8"?>
 <p:sld xmlns:a="http://schemas.openxmlformats.org/drawingml/2006/main" xmlns:p="http://schemas.openxmlformats.org/presentationml/2006/main" xmlns:r="http://schemas.openxmlformats.org/officeDocument/2006/relationships">
   <p:cSld>
     <p:spTree>

</xml_diff>